<commit_message>
Export comparison deck to PDF; fix chart overflow on five slides
Images were placed by fixed width, so taller charts ran past their slide's
callout box -- slide 5 clipped its own axis labels and legend, slide 7 ran off
the page. Now sized by fitting each chart's real aspect ratio inside the
available height.

Adds docs/Sutram_SRM_Comparison.pdf (12 pages, 16:9) exported via Keynote,
verified page by page.

Co-Authored-By: Claude Fable 5 <noreply@anthropic.com>
</commit_message>
<xml_diff>
--- a/docs/Sutram_SRM_Comparison.pptx
+++ b/docs/Sutram_SRM_Comparison.pptx
@@ -7061,30 +7061,6 @@
           </a:p>
         </p:txBody>
       </p:sp>
-      <p:pic>
-        <p:nvPicPr>
-          <p:cNvPr id="5" name="Picture 4" descr="wald.png"/>
-          <p:cNvPicPr>
-            <a:picLocks noChangeAspect="1"/>
-          </p:cNvPicPr>
-          <p:nvPr/>
-        </p:nvPicPr>
-        <p:blipFill>
-          <a:blip r:embed="rId2"/>
-          <a:stretch>
-            <a:fillRect/>
-          </a:stretch>
-        </p:blipFill>
-        <p:spPr>
-          <a:xfrm>
-            <a:off x="457200" y="1051560"/>
-            <a:ext cx="11338560" cy="3039756"/>
-          </a:xfrm>
-          <a:prstGeom prst="rect">
-            <a:avLst/>
-          </a:prstGeom>
-        </p:spPr>
-      </p:pic>
       <p:sp>
         <p:nvSpPr>
           <p:cNvPr id="6" name="Rounded Rectangle 5"/>
@@ -7215,6 +7191,30 @@
           </a:p>
         </p:txBody>
       </p:sp>
+      <p:pic>
+        <p:nvPicPr>
+          <p:cNvPr id="9" name="Picture 8" descr="image.png"/>
+          <p:cNvPicPr>
+            <a:picLocks noChangeAspect="1"/>
+          </p:cNvPicPr>
+          <p:nvPr/>
+        </p:nvPicPr>
+        <p:blipFill>
+          <a:blip r:embed="rId2"/>
+          <a:stretch>
+            <a:fillRect/>
+          </a:stretch>
+        </p:blipFill>
+        <p:spPr>
+          <a:xfrm>
+            <a:off x="475487" y="1097280"/>
+            <a:ext cx="11247120" cy="3015242"/>
+          </a:xfrm>
+          <a:prstGeom prst="rect">
+            <a:avLst/>
+          </a:prstGeom>
+        </p:spPr>
+      </p:pic>
     </p:spTree>
   </p:cSld>
   <p:clrMapOvr>
@@ -7349,30 +7349,6 @@
           </a:p>
         </p:txBody>
       </p:sp>
-      <p:pic>
-        <p:nvPicPr>
-          <p:cNvPr id="5" name="Picture 4" descr="s2s2.png"/>
-          <p:cNvPicPr>
-            <a:picLocks noChangeAspect="1"/>
-          </p:cNvPicPr>
-          <p:nvPr/>
-        </p:nvPicPr>
-        <p:blipFill>
-          <a:blip r:embed="rId2"/>
-          <a:stretch>
-            <a:fillRect/>
-          </a:stretch>
-        </p:blipFill>
-        <p:spPr>
-          <a:xfrm>
-            <a:off x="1188720" y="1143000"/>
-            <a:ext cx="9784080" cy="3438883"/>
-          </a:xfrm>
-          <a:prstGeom prst="rect">
-            <a:avLst/>
-          </a:prstGeom>
-        </p:spPr>
-      </p:pic>
       <p:sp>
         <p:nvSpPr>
           <p:cNvPr id="6" name="Rounded Rectangle 5"/>
@@ -7503,6 +7479,30 @@
           </a:p>
         </p:txBody>
       </p:sp>
+      <p:pic>
+        <p:nvPicPr>
+          <p:cNvPr id="9" name="Picture 8" descr="image.png"/>
+          <p:cNvPicPr>
+            <a:picLocks noChangeAspect="1"/>
+          </p:cNvPicPr>
+          <p:nvPr/>
+        </p:nvPicPr>
+        <p:blipFill>
+          <a:blip r:embed="rId2"/>
+          <a:stretch>
+            <a:fillRect/>
+          </a:stretch>
+        </p:blipFill>
+        <p:spPr>
+          <a:xfrm>
+            <a:off x="1252728" y="1170432"/>
+            <a:ext cx="9692640" cy="3406744"/>
+          </a:xfrm>
+          <a:prstGeom prst="rect">
+            <a:avLst/>
+          </a:prstGeom>
+        </p:spPr>
+      </p:pic>
     </p:spTree>
   </p:cSld>
   <p:clrMapOvr>
@@ -7637,30 +7637,6 @@
           </a:p>
         </p:txBody>
       </p:sp>
-      <p:pic>
-        <p:nvPicPr>
-          <p:cNvPr id="5" name="Picture 4" descr="downstream.png"/>
-          <p:cNvPicPr>
-            <a:picLocks noChangeAspect="1"/>
-          </p:cNvPicPr>
-          <p:nvPr/>
-        </p:nvPicPr>
-        <p:blipFill>
-          <a:blip r:embed="rId2"/>
-          <a:stretch>
-            <a:fillRect/>
-          </a:stretch>
-        </p:blipFill>
-        <p:spPr>
-          <a:xfrm>
-            <a:off x="1417320" y="1097280"/>
-            <a:ext cx="9326880" cy="4921820"/>
-          </a:xfrm>
-          <a:prstGeom prst="rect">
-            <a:avLst/>
-          </a:prstGeom>
-        </p:spPr>
-      </p:pic>
       <p:sp>
         <p:nvSpPr>
           <p:cNvPr id="6" name="Rounded Rectangle 5"/>
@@ -7791,6 +7767,30 @@
           </a:p>
         </p:txBody>
       </p:sp>
+      <p:pic>
+        <p:nvPicPr>
+          <p:cNvPr id="9" name="Picture 8" descr="image.png"/>
+          <p:cNvPicPr>
+            <a:picLocks noChangeAspect="1"/>
+          </p:cNvPicPr>
+          <p:nvPr/>
+        </p:nvPicPr>
+        <p:blipFill>
+          <a:blip r:embed="rId2"/>
+          <a:stretch>
+            <a:fillRect/>
+          </a:stretch>
+        </p:blipFill>
+        <p:spPr>
+          <a:xfrm>
+            <a:off x="2243581" y="1051560"/>
+            <a:ext cx="7710932" cy="4069080"/>
+          </a:xfrm>
+          <a:prstGeom prst="rect">
+            <a:avLst/>
+          </a:prstGeom>
+        </p:spPr>
+      </p:pic>
     </p:spTree>
   </p:cSld>
   <p:clrMapOvr>
@@ -7925,30 +7925,6 @@
           </a:p>
         </p:txBody>
       </p:sp>
-      <p:pic>
-        <p:nvPicPr>
-          <p:cNvPr id="5" name="Picture 4" descr="speed.png"/>
-          <p:cNvPicPr>
-            <a:picLocks noChangeAspect="1"/>
-          </p:cNvPicPr>
-          <p:nvPr/>
-        </p:nvPicPr>
-        <p:blipFill>
-          <a:blip r:embed="rId2"/>
-          <a:stretch>
-            <a:fillRect/>
-          </a:stretch>
-        </p:blipFill>
-        <p:spPr>
-          <a:xfrm>
-            <a:off x="2286000" y="1097280"/>
-            <a:ext cx="7589520" cy="4610991"/>
-          </a:xfrm>
-          <a:prstGeom prst="rect">
-            <a:avLst/>
-          </a:prstGeom>
-        </p:spPr>
-      </p:pic>
       <p:graphicFrame>
         <p:nvGraphicFramePr>
           <p:cNvPr id="6" name="Table 5"/>
@@ -8447,6 +8423,30 @@
           </a:graphicData>
         </a:graphic>
       </p:graphicFrame>
+      <p:pic>
+        <p:nvPicPr>
+          <p:cNvPr id="7" name="Picture 6" descr="image.png"/>
+          <p:cNvPicPr>
+            <a:picLocks noChangeAspect="1"/>
+          </p:cNvPicPr>
+          <p:nvPr/>
+        </p:nvPicPr>
+        <p:blipFill>
+          <a:blip r:embed="rId2"/>
+          <a:stretch>
+            <a:fillRect/>
+          </a:stretch>
+        </p:blipFill>
+        <p:spPr>
+          <a:xfrm>
+            <a:off x="2976031" y="1024128"/>
+            <a:ext cx="6246033" cy="3794760"/>
+          </a:xfrm>
+          <a:prstGeom prst="rect">
+            <a:avLst/>
+          </a:prstGeom>
+        </p:spPr>
+      </p:pic>
     </p:spTree>
   </p:cSld>
   <p:clrMapOvr>
@@ -9173,9 +9173,44 @@
           </a:graphicData>
         </a:graphic>
       </p:graphicFrame>
+      <p:sp>
+        <p:nvSpPr>
+          <p:cNvPr id="7" name="TextBox 6"/>
+          <p:cNvSpPr txBox="1"/>
+          <p:nvPr/>
+        </p:nvSpPr>
+        <p:spPr>
+          <a:xfrm>
+            <a:off x="548640" y="6355080"/>
+            <a:ext cx="11155680" cy="365760"/>
+          </a:xfrm>
+          <a:prstGeom prst="rect">
+            <a:avLst/>
+          </a:prstGeom>
+          <a:noFill/>
+        </p:spPr>
+        <p:txBody>
+          <a:bodyPr wrap="square" lIns="0" rIns="0" tIns="0" bIns="0">
+            <a:spAutoFit/>
+          </a:bodyPr>
+          <a:lstStyle/>
+          <a:p>
+            <a:pPr algn="l"/>
+            <a:r>
+              <a:rPr sz="1050" b="0">
+                <a:solidFill>
+                  <a:srgbClr val="8B949E"/>
+                </a:solidFill>
+                <a:latin typeface="Helvetica Neue"/>
+              </a:rPr>
+              <a:t>Same-day pairing matters: Puri &amp; Kotze (2022) traced invented objects to a 25–30 day acquisition gap — the model learned change as detail.</a:t>
+            </a:r>
+          </a:p>
+        </p:txBody>
+      </p:sp>
       <p:pic>
         <p:nvPicPr>
-          <p:cNvPr id="6" name="Picture 5" descr="data.png"/>
+          <p:cNvPr id="8" name="Picture 7" descr="image.png"/>
           <p:cNvPicPr>
             <a:picLocks noChangeAspect="1"/>
           </p:cNvPicPr>
@@ -9189,49 +9224,14 @@
         </p:blipFill>
         <p:spPr>
           <a:xfrm>
-            <a:off x="2377440" y="3566160"/>
-            <a:ext cx="7406640" cy="3719977"/>
+            <a:off x="3413646" y="3520440"/>
+            <a:ext cx="5370803" cy="2697480"/>
           </a:xfrm>
           <a:prstGeom prst="rect">
             <a:avLst/>
           </a:prstGeom>
         </p:spPr>
       </p:pic>
-      <p:sp>
-        <p:nvSpPr>
-          <p:cNvPr id="7" name="TextBox 6"/>
-          <p:cNvSpPr txBox="1"/>
-          <p:nvPr/>
-        </p:nvSpPr>
-        <p:spPr>
-          <a:xfrm>
-            <a:off x="548640" y="6355080"/>
-            <a:ext cx="11155680" cy="365760"/>
-          </a:xfrm>
-          <a:prstGeom prst="rect">
-            <a:avLst/>
-          </a:prstGeom>
-          <a:noFill/>
-        </p:spPr>
-        <p:txBody>
-          <a:bodyPr wrap="square" lIns="0" rIns="0" tIns="0" bIns="0">
-            <a:spAutoFit/>
-          </a:bodyPr>
-          <a:lstStyle/>
-          <a:p>
-            <a:pPr algn="l"/>
-            <a:r>
-              <a:rPr sz="1050" b="0">
-                <a:solidFill>
-                  <a:srgbClr val="8B949E"/>
-                </a:solidFill>
-                <a:latin typeface="Helvetica Neue"/>
-              </a:rPr>
-              <a:t>Same-day pairing matters: Puri &amp; Kotze (2022) traced invented objects to a 25–30 day acquisition gap — the model learned change as detail.</a:t>
-            </a:r>
-          </a:p>
-        </p:txBody>
-      </p:sp>
     </p:spTree>
   </p:cSld>
   <p:clrMapOvr>

</xml_diff>